<commit_message>
Figure 1: author-edited neutral version (cover colours matched to the background) and its 4000x2250 PNG
</commit_message>
<xml_diff>
--- a/figures/main/Fig1_manuscript_editable_neutral.pptx
+++ b/figures/main/Fig1_manuscript_editable_neutral.pptx
@@ -208,7 +208,7 @@
           <a:p>
             <a:fld id="{110C1644-9EAB-6842-ACE8-722D02F6BB62}" type="datetimeFigureOut">
               <a:rPr kumimoji="1" lang="ja-JP" altLang="en-US" smtClean="0"/>
-              <a:t>2026/4/22</a:t>
+              <a:t>2026/10/3</a:t>
             </a:fld>
             <a:endParaRPr kumimoji="1" lang="ja-JP" altLang="en-US"/>
           </a:p>
@@ -654,7 +654,7 @@
           <a:p>
             <a:fld id="{7B9A04E9-7A66-8C4B-8454-F4A2D18C006C}" type="datetimeFigureOut">
               <a:rPr kumimoji="1" lang="ja-JP" altLang="en-US" smtClean="0"/>
-              <a:t>2026/4/22</a:t>
+              <a:t>2026/10/3</a:t>
             </a:fld>
             <a:endParaRPr kumimoji="1" lang="ja-JP" altLang="en-US"/>
           </a:p>
@@ -884,7 +884,7 @@
           <a:p>
             <a:fld id="{7B9A04E9-7A66-8C4B-8454-F4A2D18C006C}" type="datetimeFigureOut">
               <a:rPr kumimoji="1" lang="ja-JP" altLang="en-US" smtClean="0"/>
-              <a:t>2026/4/22</a:t>
+              <a:t>2026/10/3</a:t>
             </a:fld>
             <a:endParaRPr kumimoji="1" lang="ja-JP" altLang="en-US"/>
           </a:p>
@@ -1124,7 +1124,7 @@
           <a:p>
             <a:fld id="{7B9A04E9-7A66-8C4B-8454-F4A2D18C006C}" type="datetimeFigureOut">
               <a:rPr kumimoji="1" lang="ja-JP" altLang="en-US" smtClean="0"/>
-              <a:t>2026/4/22</a:t>
+              <a:t>2026/10/3</a:t>
             </a:fld>
             <a:endParaRPr kumimoji="1" lang="ja-JP" altLang="en-US"/>
           </a:p>
@@ -1354,7 +1354,7 @@
           <a:p>
             <a:fld id="{7B9A04E9-7A66-8C4B-8454-F4A2D18C006C}" type="datetimeFigureOut">
               <a:rPr kumimoji="1" lang="ja-JP" altLang="en-US" smtClean="0"/>
-              <a:t>2026/4/22</a:t>
+              <a:t>2026/10/3</a:t>
             </a:fld>
             <a:endParaRPr kumimoji="1" lang="ja-JP" altLang="en-US"/>
           </a:p>
@@ -1629,7 +1629,7 @@
           <a:p>
             <a:fld id="{7B9A04E9-7A66-8C4B-8454-F4A2D18C006C}" type="datetimeFigureOut">
               <a:rPr kumimoji="1" lang="ja-JP" altLang="en-US" smtClean="0"/>
-              <a:t>2026/4/22</a:t>
+              <a:t>2026/10/3</a:t>
             </a:fld>
             <a:endParaRPr kumimoji="1" lang="ja-JP" altLang="en-US"/>
           </a:p>
@@ -1958,7 +1958,7 @@
           <a:p>
             <a:fld id="{7B9A04E9-7A66-8C4B-8454-F4A2D18C006C}" type="datetimeFigureOut">
               <a:rPr kumimoji="1" lang="ja-JP" altLang="en-US" smtClean="0"/>
-              <a:t>2026/4/22</a:t>
+              <a:t>2026/10/3</a:t>
             </a:fld>
             <a:endParaRPr kumimoji="1" lang="ja-JP" altLang="en-US"/>
           </a:p>
@@ -2434,7 +2434,7 @@
           <a:p>
             <a:fld id="{7B9A04E9-7A66-8C4B-8454-F4A2D18C006C}" type="datetimeFigureOut">
               <a:rPr kumimoji="1" lang="ja-JP" altLang="en-US" smtClean="0"/>
-              <a:t>2026/4/22</a:t>
+              <a:t>2026/10/3</a:t>
             </a:fld>
             <a:endParaRPr kumimoji="1" lang="ja-JP" altLang="en-US"/>
           </a:p>
@@ -2575,7 +2575,7 @@
           <a:p>
             <a:fld id="{7B9A04E9-7A66-8C4B-8454-F4A2D18C006C}" type="datetimeFigureOut">
               <a:rPr kumimoji="1" lang="ja-JP" altLang="en-US" smtClean="0"/>
-              <a:t>2026/4/22</a:t>
+              <a:t>2026/10/3</a:t>
             </a:fld>
             <a:endParaRPr kumimoji="1" lang="ja-JP" altLang="en-US"/>
           </a:p>
@@ -2688,7 +2688,7 @@
           <a:p>
             <a:fld id="{7B9A04E9-7A66-8C4B-8454-F4A2D18C006C}" type="datetimeFigureOut">
               <a:rPr kumimoji="1" lang="ja-JP" altLang="en-US" smtClean="0"/>
-              <a:t>2026/4/22</a:t>
+              <a:t>2026/10/3</a:t>
             </a:fld>
             <a:endParaRPr kumimoji="1" lang="ja-JP" altLang="en-US"/>
           </a:p>
@@ -3031,7 +3031,7 @@
           <a:p>
             <a:fld id="{7B9A04E9-7A66-8C4B-8454-F4A2D18C006C}" type="datetimeFigureOut">
               <a:rPr kumimoji="1" lang="ja-JP" altLang="en-US" smtClean="0"/>
-              <a:t>2026/4/22</a:t>
+              <a:t>2026/10/3</a:t>
             </a:fld>
             <a:endParaRPr kumimoji="1" lang="ja-JP" altLang="en-US"/>
           </a:p>
@@ -3319,7 +3319,7 @@
           <a:p>
             <a:fld id="{7B9A04E9-7A66-8C4B-8454-F4A2D18C006C}" type="datetimeFigureOut">
               <a:rPr kumimoji="1" lang="ja-JP" altLang="en-US" smtClean="0"/>
-              <a:t>2026/4/22</a:t>
+              <a:t>2026/10/3</a:t>
             </a:fld>
             <a:endParaRPr kumimoji="1" lang="ja-JP" altLang="en-US"/>
           </a:p>
@@ -3592,7 +3592,7 @@
           <a:p>
             <a:fld id="{7B9A04E9-7A66-8C4B-8454-F4A2D18C006C}" type="datetimeFigureOut">
               <a:rPr kumimoji="1" lang="ja-JP" altLang="en-US" smtClean="0"/>
-              <a:t>2026/4/22</a:t>
+              <a:t>2026/10/3</a:t>
             </a:fld>
             <a:endParaRPr kumimoji="1" lang="ja-JP" altLang="en-US"/>
           </a:p>
@@ -4054,6 +4054,13 @@
             <a:noFill/>
           </a:ln>
         </p:spPr>
+        <p:txBody>
+          <a:bodyPr/>
+          <a:lstStyle/>
+          <a:p>
+            <a:endParaRPr lang="ja-JP" altLang="en-US"/>
+          </a:p>
+        </p:txBody>
       </p:sp>
       <p:sp>
         <p:nvSpPr>
@@ -4063,8 +4070,8 @@
         </p:nvSpPr>
         <p:spPr>
           <a:xfrm>
-            <a:off x="3200400" y="5090160"/>
-            <a:ext cx="822960" cy="701040"/>
+            <a:off x="3187294" y="5086350"/>
+            <a:ext cx="822960" cy="766445"/>
           </a:xfrm>
           <a:prstGeom prst="rect">
             <a:avLst/>
@@ -4073,9 +4080,18 @@
             <a:srgbClr val="E5E5E5"/>
           </a:solidFill>
           <a:ln>
-            <a:noFill/>
+            <a:solidFill>
+              <a:srgbClr val="E5E5E5"/>
+            </a:solidFill>
           </a:ln>
         </p:spPr>
+        <p:txBody>
+          <a:bodyPr/>
+          <a:lstStyle/>
+          <a:p>
+            <a:endParaRPr lang="ja-JP" altLang="en-US"/>
+          </a:p>
+        </p:txBody>
       </p:sp>
       <p:sp>
         <p:nvSpPr>
@@ -4098,6 +4114,13 @@
             <a:noFill/>
           </a:ln>
         </p:spPr>
+        <p:txBody>
+          <a:bodyPr/>
+          <a:lstStyle/>
+          <a:p>
+            <a:endParaRPr lang="ja-JP" altLang="en-US"/>
+          </a:p>
+        </p:txBody>
       </p:sp>
       <p:sp>
         <p:nvSpPr>
@@ -4107,7 +4130,7 @@
         </p:nvSpPr>
         <p:spPr>
           <a:xfrm>
-            <a:off x="259080" y="338328"/>
+            <a:off x="259080" y="224027"/>
             <a:ext cx="4881250" cy="335280"/>
           </a:xfrm>
           <a:prstGeom prst="rect">
@@ -4127,7 +4150,7 @@
               </a:lnSpc>
             </a:pPr>
             <a:r>
-              <a:rPr lang="en-US" sz="2050" b="1" i="0" dirty="0">
+              <a:rPr lang="en-US" sz="2000" b="1" i="0" dirty="0">
                 <a:solidFill>
                   <a:srgbClr val="000000"/>
                 </a:solidFill>
@@ -4135,209 +4158,6 @@
                 <a:cs typeface="Arial"/>
               </a:rPr>
               <a:t>(A) Fixed, pre-defined sampling</a:t>
-            </a:r>
-          </a:p>
-        </p:txBody>
-      </p:sp>
-      <p:sp>
-        <p:nvSpPr>
-          <p:cNvPr id="14" name="cover: A_sub"/>
-          <p:cNvSpPr/>
-          <p:nvPr/>
-        </p:nvSpPr>
-        <p:spPr>
-          <a:xfrm>
-            <a:off x="768096" y="685800"/>
-            <a:ext cx="2093976" cy="265176"/>
-          </a:xfrm>
-          <a:prstGeom prst="rect">
-            <a:avLst/>
-          </a:prstGeom>
-          <a:solidFill>
-            <a:srgbClr val="E5E5E5"/>
-          </a:solidFill>
-          <a:ln>
-            <a:noFill/>
-          </a:ln>
-        </p:spPr>
-      </p:sp>
-      <p:sp>
-        <p:nvSpPr>
-          <p:cNvPr id="15" name="text: A_sub"/>
-          <p:cNvSpPr txBox="1"/>
-          <p:nvPr/>
-        </p:nvSpPr>
-        <p:spPr>
-          <a:xfrm>
-            <a:off x="698945" y="685800"/>
-            <a:ext cx="2232279" cy="265176"/>
-          </a:xfrm>
-          <a:prstGeom prst="rect">
-            <a:avLst/>
-          </a:prstGeom>
-          <a:noFill/>
-        </p:spPr>
-        <p:txBody>
-          <a:bodyPr wrap="square" lIns="0" tIns="0" rIns="0" bIns="0" anchor="ctr">
-            <a:noAutofit/>
-          </a:bodyPr>
-          <a:lstStyle/>
-          <a:p>
-            <a:pPr algn="ctr">
-              <a:lnSpc>
-                <a:spcPct val="105000"/>
-              </a:lnSpc>
-            </a:pPr>
-            <a:r>
-              <a:rPr lang="en-US" sz="1550" b="0" i="0" dirty="0">
-                <a:solidFill>
-                  <a:srgbClr val="000000"/>
-                </a:solidFill>
-                <a:latin typeface="Arial"/>
-                <a:cs typeface="Arial"/>
-              </a:rPr>
-              <a:t>(e.g., grid sampling)</a:t>
-            </a:r>
-          </a:p>
-        </p:txBody>
-      </p:sp>
-      <p:sp>
-        <p:nvSpPr>
-          <p:cNvPr id="16" name="cover: A_oneoff"/>
-          <p:cNvSpPr/>
-          <p:nvPr/>
-        </p:nvSpPr>
-        <p:spPr>
-          <a:xfrm>
-            <a:off x="2801112" y="4309872"/>
-            <a:ext cx="978408" cy="414528"/>
-          </a:xfrm>
-          <a:prstGeom prst="rect">
-            <a:avLst/>
-          </a:prstGeom>
-          <a:solidFill>
-            <a:srgbClr val="E5E5E5"/>
-          </a:solidFill>
-          <a:ln>
-            <a:noFill/>
-          </a:ln>
-        </p:spPr>
-      </p:sp>
-      <p:sp>
-        <p:nvSpPr>
-          <p:cNvPr id="17" name="text: A_oneoff"/>
-          <p:cNvSpPr txBox="1"/>
-          <p:nvPr/>
-        </p:nvSpPr>
-        <p:spPr>
-          <a:xfrm>
-            <a:off x="2796540" y="4309872"/>
-            <a:ext cx="987552" cy="414528"/>
-          </a:xfrm>
-          <a:prstGeom prst="rect">
-            <a:avLst/>
-          </a:prstGeom>
-          <a:noFill/>
-        </p:spPr>
-        <p:txBody>
-          <a:bodyPr wrap="square" lIns="0" tIns="0" rIns="0" bIns="0" anchor="ctr">
-            <a:noAutofit/>
-          </a:bodyPr>
-          <a:lstStyle/>
-          <a:p>
-            <a:pPr algn="ctr">
-              <a:lnSpc>
-                <a:spcPct val="105000"/>
-              </a:lnSpc>
-            </a:pPr>
-            <a:r>
-              <a:rPr lang="en-US" sz="1200" b="0" i="0" dirty="0">
-                <a:solidFill>
-                  <a:srgbClr val="000000"/>
-                </a:solidFill>
-                <a:latin typeface="Arial"/>
-                <a:cs typeface="Arial"/>
-              </a:rPr>
-              <a:t>One-off,</a:t>
-            </a:r>
-          </a:p>
-          <a:p>
-            <a:pPr algn="ctr">
-              <a:lnSpc>
-                <a:spcPct val="105000"/>
-              </a:lnSpc>
-            </a:pPr>
-            <a:r>
-              <a:rPr lang="en-US" sz="1200" b="0" i="0" dirty="0">
-                <a:solidFill>
-                  <a:srgbClr val="000000"/>
-                </a:solidFill>
-                <a:latin typeface="Arial"/>
-                <a:cs typeface="Arial"/>
-              </a:rPr>
-              <a:t>fixed design</a:t>
-            </a:r>
-          </a:p>
-        </p:txBody>
-      </p:sp>
-      <p:sp>
-        <p:nvSpPr>
-          <p:cNvPr id="18" name="cover: A_data"/>
-          <p:cNvSpPr/>
-          <p:nvPr/>
-        </p:nvSpPr>
-        <p:spPr>
-          <a:xfrm>
-            <a:off x="1450848" y="5224272"/>
-            <a:ext cx="1408176" cy="262128"/>
-          </a:xfrm>
-          <a:prstGeom prst="rect">
-            <a:avLst/>
-          </a:prstGeom>
-          <a:solidFill>
-            <a:srgbClr val="FFFFFF"/>
-          </a:solidFill>
-          <a:ln>
-            <a:noFill/>
-          </a:ln>
-        </p:spPr>
-      </p:sp>
-      <p:sp>
-        <p:nvSpPr>
-          <p:cNvPr id="19" name="text: A_data"/>
-          <p:cNvSpPr txBox="1"/>
-          <p:nvPr/>
-        </p:nvSpPr>
-        <p:spPr>
-          <a:xfrm>
-            <a:off x="1419416" y="5224272"/>
-            <a:ext cx="1471041" cy="262128"/>
-          </a:xfrm>
-          <a:prstGeom prst="rect">
-            <a:avLst/>
-          </a:prstGeom>
-          <a:noFill/>
-        </p:spPr>
-        <p:txBody>
-          <a:bodyPr wrap="square" lIns="0" tIns="0" rIns="0" bIns="0" anchor="ctr">
-            <a:noAutofit/>
-          </a:bodyPr>
-          <a:lstStyle/>
-          <a:p>
-            <a:pPr algn="ctr">
-              <a:lnSpc>
-                <a:spcPct val="105000"/>
-              </a:lnSpc>
-            </a:pPr>
-            <a:r>
-              <a:rPr lang="en-US" sz="1650" b="0" i="0" dirty="0">
-                <a:solidFill>
-                  <a:srgbClr val="000000"/>
-                </a:solidFill>
-                <a:latin typeface="Arial"/>
-                <a:cs typeface="Arial"/>
-              </a:rPr>
-              <a:t>Data Analysis</a:t>
             </a:r>
           </a:p>
         </p:txBody>
@@ -4363,44 +4183,11 @@
             <a:noFill/>
           </a:ln>
         </p:spPr>
-      </p:sp>
-      <p:sp>
-        <p:nvSpPr>
-          <p:cNvPr id="21" name="text: A_blind"/>
-          <p:cNvSpPr txBox="1"/>
-          <p:nvPr/>
-        </p:nvSpPr>
-        <p:spPr>
-          <a:xfrm>
-            <a:off x="368503" y="5733288"/>
-            <a:ext cx="3533242" cy="374904"/>
-          </a:xfrm>
-          <a:prstGeom prst="rect">
-            <a:avLst/>
-          </a:prstGeom>
-          <a:noFill/>
-        </p:spPr>
-        <p:txBody>
-          <a:bodyPr wrap="square" lIns="0" tIns="0" rIns="0" bIns="0" anchor="ctr">
-            <a:noAutofit/>
-          </a:bodyPr>
-          <a:lstStyle/>
-          <a:p>
-            <a:pPr algn="ctr">
-              <a:lnSpc>
-                <a:spcPct val="105000"/>
-              </a:lnSpc>
-            </a:pPr>
-            <a:r>
-              <a:rPr lang="en-US" sz="2000" b="1" i="0" dirty="0">
-                <a:solidFill>
-                  <a:srgbClr val="000000"/>
-                </a:solidFill>
-                <a:latin typeface="Arial"/>
-                <a:cs typeface="Arial"/>
-              </a:rPr>
-              <a:t>Representative coverage</a:t>
-            </a:r>
+        <p:txBody>
+          <a:bodyPr/>
+          <a:lstStyle/>
+          <a:p>
+            <a:endParaRPr lang="ja-JP" altLang="en-US"/>
           </a:p>
         </p:txBody>
       </p:sp>
@@ -4412,8 +4199,8 @@
         </p:nvSpPr>
         <p:spPr>
           <a:xfrm>
-            <a:off x="594360" y="6025896"/>
-            <a:ext cx="3060192" cy="445008"/>
+            <a:off x="594360" y="5945759"/>
+            <a:ext cx="3060192" cy="525145"/>
           </a:xfrm>
           <a:prstGeom prst="rect">
             <a:avLst/>
@@ -4425,6 +4212,13 @@
             <a:noFill/>
           </a:ln>
         </p:spPr>
+        <p:txBody>
+          <a:bodyPr/>
+          <a:lstStyle/>
+          <a:p>
+            <a:endParaRPr lang="ja-JP" altLang="en-US"/>
+          </a:p>
+        </p:txBody>
       </p:sp>
       <p:sp>
         <p:nvSpPr>
@@ -4434,7 +4228,7 @@
         </p:nvSpPr>
         <p:spPr>
           <a:xfrm>
-            <a:off x="457962" y="6025896"/>
+            <a:off x="488441" y="6035040"/>
             <a:ext cx="3332988" cy="445008"/>
           </a:xfrm>
           <a:prstGeom prst="rect">
@@ -4454,7 +4248,7 @@
               </a:lnSpc>
             </a:pPr>
             <a:r>
-              <a:rPr lang="en-US" sz="1350" b="0" i="0" dirty="0">
+              <a:rPr lang="en-US" sz="1400" b="0" i="0" dirty="0">
                 <a:solidFill>
                   <a:srgbClr val="000000"/>
                 </a:solidFill>
@@ -4471,7 +4265,7 @@
               </a:lnSpc>
             </a:pPr>
             <a:r>
-              <a:rPr lang="en-US" sz="1350" b="0" i="0" dirty="0">
+              <a:rPr lang="en-US" sz="1400" b="0" i="0" dirty="0">
                 <a:solidFill>
                   <a:srgbClr val="000000"/>
                 </a:solidFill>
@@ -4504,6 +4298,13 @@
             <a:noFill/>
           </a:ln>
         </p:spPr>
+        <p:txBody>
+          <a:bodyPr/>
+          <a:lstStyle/>
+          <a:p>
+            <a:endParaRPr lang="ja-JP" altLang="en-US"/>
+          </a:p>
+        </p:txBody>
       </p:sp>
       <p:sp>
         <p:nvSpPr>
@@ -4513,7 +4314,7 @@
         </p:nvSpPr>
         <p:spPr>
           <a:xfrm>
-            <a:off x="4419600" y="321278"/>
+            <a:off x="4419600" y="206977"/>
             <a:ext cx="7949794" cy="357188"/>
           </a:xfrm>
           <a:prstGeom prst="rect">
@@ -4533,7 +4334,7 @@
               </a:lnSpc>
             </a:pPr>
             <a:r>
-              <a:rPr lang="en-US" sz="2250" b="1" i="0" dirty="0">
+              <a:rPr lang="en-US" sz="2000" b="1" i="0" dirty="0">
                 <a:solidFill>
                   <a:srgbClr val="000000"/>
                 </a:solidFill>
@@ -4547,76 +4348,14 @@
       </p:sp>
       <p:sp>
         <p:nvSpPr>
-          <p:cNvPr id="26" name="cover: B_h1"/>
-          <p:cNvSpPr/>
-          <p:nvPr/>
-        </p:nvSpPr>
-        <p:spPr>
-          <a:xfrm>
-            <a:off x="4843272" y="856488"/>
-            <a:ext cx="1612392" cy="237744"/>
-          </a:xfrm>
-          <a:prstGeom prst="rect">
-            <a:avLst/>
-          </a:prstGeom>
-          <a:solidFill>
-            <a:srgbClr val="1C5475"/>
-          </a:solidFill>
-          <a:ln>
-            <a:noFill/>
-          </a:ln>
-        </p:spPr>
-      </p:sp>
-      <p:sp>
-        <p:nvSpPr>
-          <p:cNvPr id="27" name="text: B_h1"/>
-          <p:cNvSpPr txBox="1"/>
-          <p:nvPr/>
-        </p:nvSpPr>
-        <p:spPr>
-          <a:xfrm>
-            <a:off x="4802505" y="856488"/>
-            <a:ext cx="1693926" cy="237744"/>
-          </a:xfrm>
-          <a:prstGeom prst="rect">
-            <a:avLst/>
-          </a:prstGeom>
-          <a:noFill/>
-        </p:spPr>
-        <p:txBody>
-          <a:bodyPr wrap="square" lIns="0" tIns="0" rIns="0" bIns="0" anchor="ctr">
-            <a:noAutofit/>
-          </a:bodyPr>
-          <a:lstStyle/>
-          <a:p>
-            <a:pPr algn="ctr">
-              <a:lnSpc>
-                <a:spcPct val="105000"/>
-              </a:lnSpc>
-            </a:pPr>
-            <a:r>
-              <a:rPr lang="en-US" sz="1300" b="0" i="0" dirty="0">
-                <a:solidFill>
-                  <a:srgbClr val="FFFFFF"/>
-                </a:solidFill>
-                <a:latin typeface="Arial"/>
-                <a:cs typeface="Arial"/>
-              </a:rPr>
-              <a:t>1. Initial Sampling</a:t>
-            </a:r>
-          </a:p>
-        </p:txBody>
-      </p:sp>
-      <p:sp>
-        <p:nvSpPr>
           <p:cNvPr id="28" name="cover: B_few"/>
           <p:cNvSpPr/>
           <p:nvPr/>
         </p:nvSpPr>
         <p:spPr>
           <a:xfrm>
-            <a:off x="4852416" y="1173480"/>
-            <a:ext cx="1563624" cy="256032"/>
+            <a:off x="4843272" y="1147477"/>
+            <a:ext cx="1563624" cy="213360"/>
           </a:xfrm>
           <a:prstGeom prst="rect">
             <a:avLst/>
@@ -4628,6 +4367,13 @@
             <a:noFill/>
           </a:ln>
         </p:spPr>
+        <p:txBody>
+          <a:bodyPr/>
+          <a:lstStyle/>
+          <a:p>
+            <a:endParaRPr lang="ja-JP" altLang="en-US"/>
+          </a:p>
+        </p:txBody>
       </p:sp>
       <p:sp>
         <p:nvSpPr>
@@ -4637,7 +4383,7 @@
         </p:nvSpPr>
         <p:spPr>
           <a:xfrm>
-            <a:off x="4648391" y="1173480"/>
+            <a:off x="4653534" y="1118616"/>
             <a:ext cx="1971675" cy="256032"/>
           </a:xfrm>
           <a:prstGeom prst="rect">
@@ -4657,7 +4403,7 @@
               </a:lnSpc>
             </a:pPr>
             <a:r>
-              <a:rPr lang="en-US" sz="1250" b="0" i="0" dirty="0">
+              <a:rPr lang="en-US" sz="1400" b="0" i="0" dirty="0">
                 <a:solidFill>
                   <a:srgbClr val="000000"/>
                 </a:solidFill>
@@ -4671,36 +4417,14 @@
       </p:sp>
       <p:sp>
         <p:nvSpPr>
-          <p:cNvPr id="30" name="cover: B_h2"/>
-          <p:cNvSpPr/>
+          <p:cNvPr id="21" name="text: A_blind"/>
+          <p:cNvSpPr txBox="1"/>
           <p:nvPr/>
         </p:nvSpPr>
         <p:spPr>
           <a:xfrm>
-            <a:off x="8570976" y="822960"/>
-            <a:ext cx="2228088" cy="237744"/>
-          </a:xfrm>
-          <a:prstGeom prst="rect">
-            <a:avLst/>
-          </a:prstGeom>
-          <a:solidFill>
-            <a:srgbClr val="1C5475"/>
-          </a:solidFill>
-          <a:ln>
-            <a:noFill/>
-          </a:ln>
-        </p:spPr>
-      </p:sp>
-      <p:sp>
-        <p:nvSpPr>
-          <p:cNvPr id="31" name="text: B_h2"/>
-          <p:cNvSpPr txBox="1"/>
-          <p:nvPr/>
-        </p:nvSpPr>
-        <p:spPr>
-          <a:xfrm>
-            <a:off x="8527733" y="822960"/>
-            <a:ext cx="2314575" cy="237744"/>
+            <a:off x="357835" y="5587746"/>
+            <a:ext cx="3533242" cy="374904"/>
           </a:xfrm>
           <a:prstGeom prst="rect">
             <a:avLst/>
@@ -4719,785 +4443,14 @@
               </a:lnSpc>
             </a:pPr>
             <a:r>
-              <a:rPr lang="en-US" sz="1350" b="0" i="0" dirty="0">
-                <a:solidFill>
-                  <a:srgbClr val="FFFFFF"/>
-                </a:solidFill>
-                <a:latin typeface="Arial"/>
-                <a:cs typeface="Arial"/>
-              </a:rPr>
-              <a:t>2. Probabilistic Modeling</a:t>
-            </a:r>
-          </a:p>
-        </p:txBody>
-      </p:sp>
-      <p:sp>
-        <p:nvSpPr>
-          <p:cNvPr id="32" name="cover: B_rich"/>
-          <p:cNvSpPr/>
-          <p:nvPr/>
-        </p:nvSpPr>
-        <p:spPr>
-          <a:xfrm>
-            <a:off x="7836408" y="1164336"/>
-            <a:ext cx="758952" cy="179832"/>
-          </a:xfrm>
-          <a:prstGeom prst="rect">
-            <a:avLst/>
-          </a:prstGeom>
-          <a:solidFill>
-            <a:srgbClr val="E2EBF8"/>
-          </a:solidFill>
-          <a:ln>
-            <a:noFill/>
-          </a:ln>
-        </p:spPr>
-      </p:sp>
-      <p:sp>
-        <p:nvSpPr>
-          <p:cNvPr id="33" name="text: B_rich"/>
-          <p:cNvSpPr txBox="1"/>
-          <p:nvPr/>
-        </p:nvSpPr>
-        <p:spPr>
-          <a:xfrm>
-            <a:off x="7831836" y="1143127"/>
-            <a:ext cx="768096" cy="222250"/>
-          </a:xfrm>
-          <a:prstGeom prst="rect">
-            <a:avLst/>
-          </a:prstGeom>
-          <a:noFill/>
-        </p:spPr>
-        <p:txBody>
-          <a:bodyPr wrap="square" lIns="0" tIns="0" rIns="0" bIns="0" anchor="ctr">
-            <a:noAutofit/>
-          </a:bodyPr>
-          <a:lstStyle/>
-          <a:p>
-            <a:pPr algn="ctr">
-              <a:lnSpc>
-                <a:spcPct val="105000"/>
-              </a:lnSpc>
-            </a:pPr>
-            <a:r>
-              <a:rPr lang="en-US" sz="1400" b="0" i="0" dirty="0">
+              <a:rPr lang="en-US" sz="2000" b="1" i="0" dirty="0">
                 <a:solidFill>
                   <a:srgbClr val="000000"/>
                 </a:solidFill>
                 <a:latin typeface="Arial"/>
                 <a:cs typeface="Arial"/>
               </a:rPr>
-              <a:t>Richness</a:t>
-            </a:r>
-          </a:p>
-        </p:txBody>
-      </p:sp>
-      <p:sp>
-        <p:nvSpPr>
-          <p:cNvPr id="34" name="cover: B_uniq"/>
-          <p:cNvSpPr/>
-          <p:nvPr/>
-        </p:nvSpPr>
-        <p:spPr>
-          <a:xfrm>
-            <a:off x="9214104" y="1161288"/>
-            <a:ext cx="963168" cy="213360"/>
-          </a:xfrm>
-          <a:prstGeom prst="rect">
-            <a:avLst/>
-          </a:prstGeom>
-          <a:solidFill>
-            <a:srgbClr val="E2EBF8"/>
-          </a:solidFill>
-          <a:ln>
-            <a:noFill/>
-          </a:ln>
-        </p:spPr>
-      </p:sp>
-      <p:sp>
-        <p:nvSpPr>
-          <p:cNvPr id="35" name="text: B_uniq"/>
-          <p:cNvSpPr txBox="1"/>
-          <p:nvPr/>
-        </p:nvSpPr>
-        <p:spPr>
-          <a:xfrm>
-            <a:off x="9198483" y="1152874"/>
-            <a:ext cx="994410" cy="230188"/>
-          </a:xfrm>
-          <a:prstGeom prst="rect">
-            <a:avLst/>
-          </a:prstGeom>
-          <a:noFill/>
-        </p:spPr>
-        <p:txBody>
-          <a:bodyPr wrap="square" lIns="0" tIns="0" rIns="0" bIns="0" anchor="ctr">
-            <a:noAutofit/>
-          </a:bodyPr>
-          <a:lstStyle/>
-          <a:p>
-            <a:pPr algn="ctr">
-              <a:lnSpc>
-                <a:spcPct val="105000"/>
-              </a:lnSpc>
-            </a:pPr>
-            <a:r>
-              <a:rPr lang="en-US" sz="1450" b="0" i="0" dirty="0">
-                <a:solidFill>
-                  <a:srgbClr val="000000"/>
-                </a:solidFill>
-                <a:latin typeface="Arial"/>
-                <a:cs typeface="Arial"/>
-              </a:rPr>
-              <a:t>Uniqueness</a:t>
-            </a:r>
-          </a:p>
-        </p:txBody>
-      </p:sp>
-      <p:sp>
-        <p:nvSpPr>
-          <p:cNvPr id="36" name="cover: B_unc"/>
-          <p:cNvSpPr/>
-          <p:nvPr/>
-        </p:nvSpPr>
-        <p:spPr>
-          <a:xfrm>
-            <a:off x="10713720" y="1164336"/>
-            <a:ext cx="929640" cy="213360"/>
-          </a:xfrm>
-          <a:prstGeom prst="rect">
-            <a:avLst/>
-          </a:prstGeom>
-          <a:solidFill>
-            <a:srgbClr val="E2EBF8"/>
-          </a:solidFill>
-          <a:ln>
-            <a:noFill/>
-          </a:ln>
-        </p:spPr>
-      </p:sp>
-      <p:sp>
-        <p:nvSpPr>
-          <p:cNvPr id="37" name="text: B_unc"/>
-          <p:cNvSpPr txBox="1"/>
-          <p:nvPr/>
-        </p:nvSpPr>
-        <p:spPr>
-          <a:xfrm>
-            <a:off x="10707053" y="1164336"/>
-            <a:ext cx="942975" cy="213360"/>
-          </a:xfrm>
-          <a:prstGeom prst="rect">
-            <a:avLst/>
-          </a:prstGeom>
-          <a:noFill/>
-        </p:spPr>
-        <p:txBody>
-          <a:bodyPr wrap="square" lIns="0" tIns="0" rIns="0" bIns="0" anchor="ctr">
-            <a:noAutofit/>
-          </a:bodyPr>
-          <a:lstStyle/>
-          <a:p>
-            <a:pPr algn="ctr">
-              <a:lnSpc>
-                <a:spcPct val="105000"/>
-              </a:lnSpc>
-            </a:pPr>
-            <a:r>
-              <a:rPr lang="en-US" sz="1250" b="0" i="0" dirty="0">
-                <a:solidFill>
-                  <a:srgbClr val="000000"/>
-                </a:solidFill>
-                <a:latin typeface="Arial"/>
-                <a:cs typeface="Arial"/>
-              </a:rPr>
-              <a:t>Uncertainty</a:t>
-            </a:r>
-          </a:p>
-        </p:txBody>
-      </p:sp>
-      <p:sp>
-        <p:nvSpPr>
-          <p:cNvPr id="38" name="cover: B_update"/>
-          <p:cNvSpPr/>
-          <p:nvPr/>
-        </p:nvSpPr>
-        <p:spPr>
-          <a:xfrm>
-            <a:off x="4748784" y="3361944"/>
-            <a:ext cx="1731264" cy="213360"/>
-          </a:xfrm>
-          <a:prstGeom prst="rect">
-            <a:avLst/>
-          </a:prstGeom>
-          <a:solidFill>
-            <a:srgbClr val="D8E6F5"/>
-          </a:solidFill>
-          <a:ln>
-            <a:noFill/>
-          </a:ln>
-        </p:spPr>
-      </p:sp>
-      <p:sp>
-        <p:nvSpPr>
-          <p:cNvPr id="39" name="text: B_update"/>
-          <p:cNvSpPr txBox="1"/>
-          <p:nvPr/>
-        </p:nvSpPr>
-        <p:spPr>
-          <a:xfrm>
-            <a:off x="4722876" y="3361944"/>
-            <a:ext cx="1783080" cy="213360"/>
-          </a:xfrm>
-          <a:prstGeom prst="rect">
-            <a:avLst/>
-          </a:prstGeom>
-          <a:noFill/>
-        </p:spPr>
-        <p:txBody>
-          <a:bodyPr wrap="square" lIns="0" tIns="0" rIns="0" bIns="0" anchor="ctr">
-            <a:noAutofit/>
-          </a:bodyPr>
-          <a:lstStyle/>
-          <a:p>
-            <a:pPr algn="ctr">
-              <a:lnSpc>
-                <a:spcPct val="105000"/>
-              </a:lnSpc>
-            </a:pPr>
-            <a:r>
-              <a:rPr lang="en-US" sz="1300" b="0" i="0" dirty="0">
-                <a:solidFill>
-                  <a:srgbClr val="000000"/>
-                </a:solidFill>
-                <a:latin typeface="Arial"/>
-                <a:cs typeface="Arial"/>
-              </a:rPr>
-              <a:t>Update with new data</a:t>
-            </a:r>
-          </a:p>
-        </p:txBody>
-      </p:sp>
-      <p:sp>
-        <p:nvSpPr>
-          <p:cNvPr id="40" name="cover: B_max"/>
-          <p:cNvSpPr/>
-          <p:nvPr/>
-        </p:nvSpPr>
-        <p:spPr>
-          <a:xfrm>
-            <a:off x="7510272" y="3227832"/>
-            <a:ext cx="2356104" cy="530352"/>
-          </a:xfrm>
-          <a:prstGeom prst="rect">
-            <a:avLst/>
-          </a:prstGeom>
-          <a:solidFill>
-            <a:srgbClr val="D8E6F5"/>
-          </a:solidFill>
-          <a:ln>
-            <a:noFill/>
-          </a:ln>
-        </p:spPr>
-      </p:sp>
-      <p:sp>
-        <p:nvSpPr>
-          <p:cNvPr id="41" name="text: B_max"/>
-          <p:cNvSpPr txBox="1"/>
-          <p:nvPr/>
-        </p:nvSpPr>
-        <p:spPr>
-          <a:xfrm>
-            <a:off x="7459370" y="3227832"/>
-            <a:ext cx="2457907" cy="530352"/>
-          </a:xfrm>
-          <a:prstGeom prst="rect">
-            <a:avLst/>
-          </a:prstGeom>
-          <a:noFill/>
-        </p:spPr>
-        <p:txBody>
-          <a:bodyPr wrap="square" lIns="0" tIns="0" rIns="0" bIns="0" anchor="ctr">
-            <a:noAutofit/>
-          </a:bodyPr>
-          <a:lstStyle/>
-          <a:p>
-            <a:pPr algn="ctr">
-              <a:lnSpc>
-                <a:spcPct val="105000"/>
-              </a:lnSpc>
-            </a:pPr>
-            <a:r>
-              <a:rPr lang="en-US" sz="1600" b="1" i="0" dirty="0">
-                <a:solidFill>
-                  <a:srgbClr val="000000"/>
-                </a:solidFill>
-                <a:latin typeface="Arial"/>
-                <a:cs typeface="Arial"/>
-              </a:rPr>
-              <a:t>Maximize information</a:t>
-            </a:r>
-          </a:p>
-          <a:p>
-            <a:pPr algn="ctr">
-              <a:lnSpc>
-                <a:spcPct val="105000"/>
-              </a:lnSpc>
-            </a:pPr>
-            <a:r>
-              <a:rPr lang="en-US" sz="1600" b="1" i="0" dirty="0">
-                <a:solidFill>
-                  <a:srgbClr val="000000"/>
-                </a:solidFill>
-                <a:latin typeface="Arial"/>
-                <a:cs typeface="Arial"/>
-              </a:rPr>
-              <a:t>gained per sample</a:t>
-            </a:r>
-          </a:p>
-        </p:txBody>
-      </p:sp>
-      <p:sp>
-        <p:nvSpPr>
-          <p:cNvPr id="42" name="cover: B_weight"/>
-          <p:cNvSpPr/>
-          <p:nvPr/>
-        </p:nvSpPr>
-        <p:spPr>
-          <a:xfrm>
-            <a:off x="9101328" y="3968496"/>
-            <a:ext cx="1563624" cy="249936"/>
-          </a:xfrm>
-          <a:prstGeom prst="rect">
-            <a:avLst/>
-          </a:prstGeom>
-          <a:solidFill>
-            <a:srgbClr val="D8E6F5"/>
-          </a:solidFill>
-          <a:ln>
-            <a:noFill/>
-          </a:ln>
-        </p:spPr>
-      </p:sp>
-      <p:sp>
-        <p:nvSpPr>
-          <p:cNvPr id="43" name="text: B_weight"/>
-          <p:cNvSpPr txBox="1"/>
-          <p:nvPr/>
-        </p:nvSpPr>
-        <p:spPr>
-          <a:xfrm>
-            <a:off x="9060180" y="3968496"/>
-            <a:ext cx="1645920" cy="249936"/>
-          </a:xfrm>
-          <a:prstGeom prst="rect">
-            <a:avLst/>
-          </a:prstGeom>
-          <a:noFill/>
-        </p:spPr>
-        <p:txBody>
-          <a:bodyPr wrap="square" lIns="0" tIns="0" rIns="0" bIns="0" anchor="ctr">
-            <a:noAutofit/>
-          </a:bodyPr>
-          <a:lstStyle/>
-          <a:p>
-            <a:pPr algn="ctr">
-              <a:lnSpc>
-                <a:spcPct val="105000"/>
-              </a:lnSpc>
-            </a:pPr>
-            <a:r>
-              <a:rPr lang="en-US" sz="1500" b="0" i="0" dirty="0">
-                <a:solidFill>
-                  <a:srgbClr val="000000"/>
-                </a:solidFill>
-                <a:latin typeface="Arial"/>
-                <a:cs typeface="Arial"/>
-              </a:rPr>
-              <a:t>Weight &amp; Combine</a:t>
-            </a:r>
-          </a:p>
-        </p:txBody>
-      </p:sp>
-      <p:sp>
-        <p:nvSpPr>
-          <p:cNvPr id="44" name="cover: B_h4"/>
-          <p:cNvSpPr/>
-          <p:nvPr/>
-        </p:nvSpPr>
-        <p:spPr>
-          <a:xfrm>
-            <a:off x="5748528" y="4056888"/>
-            <a:ext cx="1947672" cy="237744"/>
-          </a:xfrm>
-          <a:prstGeom prst="rect">
-            <a:avLst/>
-          </a:prstGeom>
-          <a:solidFill>
-            <a:srgbClr val="1C5475"/>
-          </a:solidFill>
-          <a:ln>
-            <a:noFill/>
-          </a:ln>
-        </p:spPr>
-      </p:sp>
-      <p:sp>
-        <p:nvSpPr>
-          <p:cNvPr id="45" name="text: B_h4"/>
-          <p:cNvSpPr txBox="1"/>
-          <p:nvPr/>
-        </p:nvSpPr>
-        <p:spPr>
-          <a:xfrm>
-            <a:off x="5693664" y="4056698"/>
-            <a:ext cx="2057400" cy="238125"/>
-          </a:xfrm>
-          <a:prstGeom prst="rect">
-            <a:avLst/>
-          </a:prstGeom>
-          <a:noFill/>
-        </p:spPr>
-        <p:txBody>
-          <a:bodyPr wrap="square" lIns="0" tIns="0" rIns="0" bIns="0" anchor="ctr">
-            <a:noAutofit/>
-          </a:bodyPr>
-          <a:lstStyle/>
-          <a:p>
-            <a:pPr algn="ctr">
-              <a:lnSpc>
-                <a:spcPct val="105000"/>
-              </a:lnSpc>
-            </a:pPr>
-            <a:r>
-              <a:rPr lang="en-US" sz="1500" b="0" i="0" dirty="0">
-                <a:solidFill>
-                  <a:srgbClr val="FFFFFF"/>
-                </a:solidFill>
-                <a:latin typeface="Arial"/>
-                <a:cs typeface="Arial"/>
-              </a:rPr>
-              <a:t>4. Targeted Sampling</a:t>
-            </a:r>
-          </a:p>
-        </p:txBody>
-      </p:sp>
-      <p:sp>
-        <p:nvSpPr>
-          <p:cNvPr id="46" name="cover: B_h3"/>
-          <p:cNvSpPr/>
-          <p:nvPr/>
-        </p:nvSpPr>
-        <p:spPr>
-          <a:xfrm>
-            <a:off x="9649968" y="4459224"/>
-            <a:ext cx="2054352" cy="234696"/>
-          </a:xfrm>
-          <a:prstGeom prst="rect">
-            <a:avLst/>
-          </a:prstGeom>
-          <a:solidFill>
-            <a:srgbClr val="1C5475"/>
-          </a:solidFill>
-          <a:ln>
-            <a:noFill/>
-          </a:ln>
-        </p:spPr>
-      </p:sp>
-      <p:sp>
-        <p:nvSpPr>
-          <p:cNvPr id="47" name="text: B_h3"/>
-          <p:cNvSpPr txBox="1"/>
-          <p:nvPr/>
-        </p:nvSpPr>
-        <p:spPr>
-          <a:xfrm>
-            <a:off x="9612440" y="4459224"/>
-            <a:ext cx="2129409" cy="234696"/>
-          </a:xfrm>
-          <a:prstGeom prst="rect">
-            <a:avLst/>
-          </a:prstGeom>
-          <a:noFill/>
-        </p:spPr>
-        <p:txBody>
-          <a:bodyPr wrap="square" lIns="0" tIns="0" rIns="0" bIns="0" anchor="ctr">
-            <a:noAutofit/>
-          </a:bodyPr>
-          <a:lstStyle/>
-          <a:p>
-            <a:pPr algn="ctr">
-              <a:lnSpc>
-                <a:spcPct val="105000"/>
-              </a:lnSpc>
-            </a:pPr>
-            <a:r>
-              <a:rPr lang="en-US" sz="1350" b="0" i="0" dirty="0">
-                <a:solidFill>
-                  <a:srgbClr val="FFFFFF"/>
-                </a:solidFill>
-                <a:latin typeface="Arial"/>
-                <a:cs typeface="Arial"/>
-              </a:rPr>
-              <a:t>3. Acquisition Function</a:t>
-            </a:r>
-          </a:p>
-        </p:txBody>
-      </p:sp>
-      <p:sp>
-        <p:nvSpPr>
-          <p:cNvPr id="48" name="cover: B_ax"/>
-          <p:cNvSpPr/>
-          <p:nvPr/>
-        </p:nvSpPr>
-        <p:spPr>
-          <a:xfrm>
-            <a:off x="10585704" y="4779264"/>
-            <a:ext cx="374904" cy="213360"/>
-          </a:xfrm>
-          <a:prstGeom prst="rect">
-            <a:avLst/>
-          </a:prstGeom>
-          <a:solidFill>
-            <a:srgbClr val="E2EBF8"/>
-          </a:solidFill>
-          <a:ln>
-            <a:noFill/>
-          </a:ln>
-        </p:spPr>
-      </p:sp>
-      <p:sp>
-        <p:nvSpPr>
-          <p:cNvPr id="49" name="text: B_ax"/>
-          <p:cNvSpPr txBox="1"/>
-          <p:nvPr/>
-        </p:nvSpPr>
-        <p:spPr>
-          <a:xfrm>
-            <a:off x="10585704" y="4779264"/>
-            <a:ext cx="374904" cy="213360"/>
-          </a:xfrm>
-          <a:prstGeom prst="rect">
-            <a:avLst/>
-          </a:prstGeom>
-          <a:noFill/>
-        </p:spPr>
-        <p:txBody>
-          <a:bodyPr wrap="square" lIns="0" tIns="0" rIns="0" bIns="0" anchor="ctr">
-            <a:noAutofit/>
-          </a:bodyPr>
-          <a:lstStyle/>
-          <a:p>
-            <a:pPr algn="ctr">
-              <a:lnSpc>
-                <a:spcPct val="105000"/>
-              </a:lnSpc>
-            </a:pPr>
-            <a:r>
-              <a:rPr lang="en-US" sz="1150" b="0" i="1" dirty="0">
-                <a:solidFill>
-                  <a:srgbClr val="000000"/>
-                </a:solidFill>
-                <a:latin typeface="Cambria Math"/>
-                <a:cs typeface="Cambria Math"/>
-              </a:rPr>
-              <a:t>a(x)</a:t>
-            </a:r>
-          </a:p>
-        </p:txBody>
-      </p:sp>
-      <p:sp>
-        <p:nvSpPr>
-          <p:cNvPr id="50" name="cover: B_select"/>
-          <p:cNvSpPr/>
-          <p:nvPr/>
-        </p:nvSpPr>
-        <p:spPr>
-          <a:xfrm>
-            <a:off x="8049768" y="5876544"/>
-            <a:ext cx="1213104" cy="216408"/>
-          </a:xfrm>
-          <a:prstGeom prst="rect">
-            <a:avLst/>
-          </a:prstGeom>
-          <a:solidFill>
-            <a:srgbClr val="D8E6F5"/>
-          </a:solidFill>
-          <a:ln>
-            <a:noFill/>
-          </a:ln>
-        </p:spPr>
-      </p:sp>
-      <p:sp>
-        <p:nvSpPr>
-          <p:cNvPr id="51" name="text: B_select"/>
-          <p:cNvSpPr txBox="1"/>
-          <p:nvPr/>
-        </p:nvSpPr>
-        <p:spPr>
-          <a:xfrm>
-            <a:off x="8039100" y="5876544"/>
-            <a:ext cx="1234440" cy="216408"/>
-          </a:xfrm>
-          <a:prstGeom prst="rect">
-            <a:avLst/>
-          </a:prstGeom>
-          <a:noFill/>
-        </p:spPr>
-        <p:txBody>
-          <a:bodyPr wrap="square" lIns="0" tIns="0" rIns="0" bIns="0" anchor="ctr">
-            <a:noAutofit/>
-          </a:bodyPr>
-          <a:lstStyle/>
-          <a:p>
-            <a:pPr algn="ctr">
-              <a:lnSpc>
-                <a:spcPct val="105000"/>
-              </a:lnSpc>
-            </a:pPr>
-            <a:r>
-              <a:rPr lang="en-US" sz="1200" b="0" i="0" dirty="0">
-                <a:solidFill>
-                  <a:srgbClr val="000000"/>
-                </a:solidFill>
-                <a:latin typeface="Arial"/>
-                <a:cs typeface="Arial"/>
-              </a:rPr>
-              <a:t>Select top </a:t>
-            </a:r>
-            <a:r>
-              <a:rPr lang="en-US" sz="1200" b="0" i="1" dirty="0">
-                <a:solidFill>
-                  <a:srgbClr val="000000"/>
-                </a:solidFill>
-                <a:latin typeface="Cambria Math"/>
-                <a:cs typeface="Cambria Math"/>
-              </a:rPr>
-              <a:t>a(x)</a:t>
-            </a:r>
-          </a:p>
-        </p:txBody>
-      </p:sp>
-      <p:sp>
-        <p:nvSpPr>
-          <p:cNvPr id="52" name="cover: B_legend1"/>
-          <p:cNvSpPr/>
-          <p:nvPr/>
-        </p:nvSpPr>
-        <p:spPr>
-          <a:xfrm>
-            <a:off x="5029200" y="6035040"/>
-            <a:ext cx="1146048" cy="213360"/>
-          </a:xfrm>
-          <a:prstGeom prst="rect">
-            <a:avLst/>
-          </a:prstGeom>
-          <a:solidFill>
-            <a:srgbClr val="D8E6F5"/>
-          </a:solidFill>
-          <a:ln>
-            <a:noFill/>
-          </a:ln>
-        </p:spPr>
-      </p:sp>
-      <p:sp>
-        <p:nvSpPr>
-          <p:cNvPr id="53" name="text: B_legend1"/>
-          <p:cNvSpPr txBox="1"/>
-          <p:nvPr/>
-        </p:nvSpPr>
-        <p:spPr>
-          <a:xfrm>
-            <a:off x="5029200" y="6035040"/>
-            <a:ext cx="1200150" cy="213360"/>
-          </a:xfrm>
-          <a:prstGeom prst="rect">
-            <a:avLst/>
-          </a:prstGeom>
-          <a:noFill/>
-        </p:spPr>
-        <p:txBody>
-          <a:bodyPr wrap="square" lIns="0" tIns="0" rIns="0" bIns="0" anchor="ctr">
-            <a:noAutofit/>
-          </a:bodyPr>
-          <a:lstStyle/>
-          <a:p>
-            <a:pPr algn="l">
-              <a:lnSpc>
-                <a:spcPct val="105000"/>
-              </a:lnSpc>
-            </a:pPr>
-            <a:r>
-              <a:rPr lang="en-US" sz="1250" b="0" i="0" dirty="0">
-                <a:solidFill>
-                  <a:srgbClr val="000000"/>
-                </a:solidFill>
-                <a:latin typeface="Arial"/>
-                <a:cs typeface="Arial"/>
-              </a:rPr>
-              <a:t>Current points</a:t>
-            </a:r>
-          </a:p>
-        </p:txBody>
-      </p:sp>
-      <p:sp>
-        <p:nvSpPr>
-          <p:cNvPr id="54" name="cover: B_legend2"/>
-          <p:cNvSpPr/>
-          <p:nvPr/>
-        </p:nvSpPr>
-        <p:spPr>
-          <a:xfrm>
-            <a:off x="5038344" y="6336792"/>
-            <a:ext cx="2042160" cy="213360"/>
-          </a:xfrm>
-          <a:prstGeom prst="rect">
-            <a:avLst/>
-          </a:prstGeom>
-          <a:solidFill>
-            <a:srgbClr val="D8E6F5"/>
-          </a:solidFill>
-          <a:ln>
-            <a:noFill/>
-          </a:ln>
-        </p:spPr>
-      </p:sp>
-      <p:sp>
-        <p:nvSpPr>
-          <p:cNvPr id="55" name="text: B_legend2"/>
-          <p:cNvSpPr txBox="1"/>
-          <p:nvPr/>
-        </p:nvSpPr>
-        <p:spPr>
-          <a:xfrm>
-            <a:off x="5038344" y="6336792"/>
-            <a:ext cx="2139696" cy="213360"/>
-          </a:xfrm>
-          <a:prstGeom prst="rect">
-            <a:avLst/>
-          </a:prstGeom>
-          <a:noFill/>
-        </p:spPr>
-        <p:txBody>
-          <a:bodyPr wrap="square" lIns="0" tIns="0" rIns="0" bIns="0" anchor="ctr">
-            <a:noAutofit/>
-          </a:bodyPr>
-          <a:lstStyle/>
-          <a:p>
-            <a:pPr algn="l">
-              <a:lnSpc>
-                <a:spcPct val="105000"/>
-              </a:lnSpc>
-            </a:pPr>
-            <a:r>
-              <a:rPr lang="en-US" sz="1300" b="0" i="0" dirty="0">
-                <a:solidFill>
-                  <a:srgbClr val="000000"/>
-                </a:solidFill>
-                <a:latin typeface="Arial"/>
-                <a:cs typeface="Arial"/>
-              </a:rPr>
-              <a:t>Next BAS-selected points</a:t>
+              <a:t>Representative coverage</a:t>
             </a:r>
           </a:p>
         </p:txBody>

</xml_diff>